<commit_message>
style: redesign methodology slide with updated card styling, typography, and cyclic SVG indicators
</commit_message>
<xml_diff>
--- a/docs/presentation/file-3/slide-14-vdg-algorithm.pptx
+++ b/docs/presentation/file-3/slide-14-vdg-algorithm.pptx
@@ -1008,10 +1008,8 @@
             <a:off x="3086100" y="1695450"/>
             <a:ext cx="228600" cy="2133600"/>
           </a:xfrm>
-          <a:prstGeom prst="roundRect">
-            <a:avLst>
-              <a:gd name="adj" fmla="val 66667"/>
-            </a:avLst>
+          <a:prstGeom prst="rightBracket">
+            <a:avLst/>
           </a:prstGeom>
           <a:ln w="28575">
             <a:solidFill>
@@ -1708,14 +1706,12 @@
           <p:nvPr/>
         </p:nvSpPr>
         <p:spPr>
-          <a:xfrm>
-            <a:off x="2362200" y="4552950"/>
-            <a:ext cx="7467600" cy="228600"/>
-          </a:xfrm>
-          <a:prstGeom prst="roundRect">
-            <a:avLst>
-              <a:gd name="adj" fmla="val 50000"/>
-            </a:avLst>
+          <a:xfrm rot="5400000">
+            <a:off x="5981700" y="933450"/>
+            <a:ext cx="228600" cy="7467600"/>
+          </a:xfrm>
+          <a:prstGeom prst="rightBracket">
+            <a:avLst/>
           </a:prstGeom>
           <a:ln w="28575">
             <a:solidFill>
@@ -1732,8 +1728,8 @@
           <p:nvPr/>
         </p:nvSpPr>
         <p:spPr>
-          <a:xfrm>
-            <a:off x="5791200" y="4419600"/>
+          <a:xfrm rot="10800000">
+            <a:off x="5791200" y="4400550"/>
             <a:ext cx="133350" cy="133350"/>
           </a:xfrm>
           <a:prstGeom prst="triangle">

</xml_diff>